<commit_message>
v1.2.0: Integrity Layer hardening — SystemConfig thresholds + grace window, hatched stale tiles, evidence ZIP export, async Monte Carlo worker + fan chart, scenario rebase-on-merge, signed expiring approval links, benefits waterfall
</commit_message>
<xml_diff>
--- a/sales-deck/PM-Control-Tower-Sales-Deck.pptx
+++ b/sales-deck/PM-Control-Tower-Sales-Deck.pptx
@@ -14682,7 +14682,7 @@
                 <a:ea typeface="Segoe UI" pitchFamily="34" charset="-122"/>
                 <a:cs typeface="Segoe UI" pitchFamily="34" charset="-120"/>
               </a:rPr>
-              <a:t>The dashboard tells you when it is lying — DATA AS OF chips, degrading tiles</a:t>
+              <a:t>The dashboard tells you when it is lying — DATA AS OF chips, hatched stale tiles</a:t>
             </a:r>
             <a:endParaRPr lang="en-US" sz="1150" dirty="0"/>
           </a:p>
@@ -14814,7 +14814,7 @@
                 <a:ea typeface="Segoe UI" pitchFamily="34" charset="-122"/>
                 <a:cs typeface="Segoe UI" pitchFamily="34" charset="-120"/>
               </a:rPr>
-              <a:t>SHA-256 tamper-evident chain; verification pinpoints altered records</a:t>
+              <a:t>SHA-256 tamper-evident chain; ZIP export; verification pinpoints altered records</a:t>
             </a:r>
             <a:endParaRPr lang="en-US" sz="1150" dirty="0"/>
           </a:p>
@@ -14946,7 +14946,7 @@
                 <a:ea typeface="Segoe UI" pitchFamily="34" charset="-122"/>
                 <a:cs typeface="Segoe UI" pitchFamily="34" charset="-120"/>
               </a:rPr>
-              <a:t>Seeded Monte Carlo over the real CPM engine — honest date ranges</a:t>
+              <a:t>Seeded Monte Carlo on an async worker — honest P50–P80 date ranges</a:t>
             </a:r>
             <a:endParaRPr lang="en-US" sz="1150" dirty="0"/>
           </a:p>
@@ -15210,7 +15210,7 @@
                 <a:ea typeface="Segoe UI" pitchFamily="34" charset="-122"/>
                 <a:cs typeface="Segoe UI" pitchFamily="34" charset="-120"/>
               </a:rPr>
-              <a:t>Test decisions on a clone; merge as a governed Change Request</a:t>
+              <a:t>Test decisions on a clone; drift-aware rebase merge as a Change Request</a:t>
             </a:r>
             <a:endParaRPr lang="en-US" sz="1150" dirty="0"/>
           </a:p>
@@ -15342,7 +15342,7 @@
                 <a:ea typeface="Segoe UI" pitchFamily="34" charset="-122"/>
                 <a:cs typeface="Segoe UI" pitchFamily="34" charset="-120"/>
               </a:rPr>
-              <a:t>AI drafts, humans approve, audit captures both — never auto-executes</a:t>
+              <a:t>AI drafts, humans approve via signed expiring links — never auto-executes</a:t>
             </a:r>
             <a:endParaRPr lang="en-US" sz="1150" dirty="0"/>
           </a:p>

</xml_diff>